<commit_message>
Audit brand and launch claims against current platform behavior
</commit_message>
<xml_diff>
--- a/output/presentations/LakeLife-Recruitment-Pitch.pptx
+++ b/output/presentations/LakeLife-Recruitment-Pitch.pptx
@@ -2,15 +2,15 @@
 <file path=ppt/presentation.xml><?xml version="1.0" encoding="utf-8"?>
 <p:presentation xmlns:p="http://schemas.openxmlformats.org/presentationml/2006/main">
   <p:sldMasterIdLst>
-    <p:sldMasterId xmlns:r="http://schemas.openxmlformats.org/officeDocument/2006/relationships" id="2147483648" r:id="R25b6b4a103fe4db1"/>
+    <p:sldMasterId xmlns:r="http://schemas.openxmlformats.org/officeDocument/2006/relationships" id="2147483648" r:id="R1d3e9f9741e2456f"/>
   </p:sldMasterIdLst>
   <p:notesMasterIdLst>
-    <p:notesMasterId xmlns:r="http://schemas.openxmlformats.org/officeDocument/2006/relationships" r:id="R160625476b1b408b"/>
+    <p:notesMasterId xmlns:r="http://schemas.openxmlformats.org/officeDocument/2006/relationships" r:id="Raef91dc4ca594377"/>
   </p:notesMasterIdLst>
   <p:sldIdLst>
-    <p:sldId xmlns:r="http://schemas.openxmlformats.org/officeDocument/2006/relationships" id="256" r:id="R6cf306b84f31473b"/>
-    <p:sldId xmlns:r="http://schemas.openxmlformats.org/officeDocument/2006/relationships" id="257" r:id="R7aec1b211f4b4a53"/>
-    <p:sldId xmlns:r="http://schemas.openxmlformats.org/officeDocument/2006/relationships" id="258" r:id="R87a11c62122c4c1e"/>
+    <p:sldId xmlns:r="http://schemas.openxmlformats.org/officeDocument/2006/relationships" id="256" r:id="R50e68c81d3d64957"/>
+    <p:sldId xmlns:r="http://schemas.openxmlformats.org/officeDocument/2006/relationships" id="257" r:id="R7ce8d932063c487a"/>
+    <p:sldId xmlns:r="http://schemas.openxmlformats.org/officeDocument/2006/relationships" id="258" r:id="R64b70b2462e84c4b"/>
   </p:sldIdLst>
   <p:sldSz cx="12192000" cy="6858000"/>
   <p:notesSz cx="6858000" cy="9144000"/>
@@ -524,7 +524,7 @@
           </a:p>
           <a:p xmlns:a="http://schemas.openxmlformats.org/drawingml/2006/main">
             <a:r>
-              <a:t>Sources: lakelife.html (tagline, service range and visual identity), AGENTS.md (all-in price, photo gate and change approval), lakelife-beta-launch-plan.md sections 4 and 5. Local sources reviewed 17 October 2026. The imagery is original prototype service artwork, not job evidence.</a:t>
+              <a:t>Sources: src/app/page.tsx; src/app/book/actions.ts; src/app/book/page.tsx; src/app/vendor/actions.ts; src/app/approvals/actions.ts. Current pricing permits an unpriced request awaiting a crew quote. The original prototype supplies visuals only; old universal 30% economics are superseded on crew-priced work. Local sources reviewed 17 October 2026. The imagery is original prototype service artwork, not job evidence.</a:t>
             </a:r>
           </a:p>
         </p:txBody>
@@ -594,7 +594,7 @@
           <a:lstStyle xmlns:a="http://schemas.openxmlformats.org/drawingml/2006/main"/>
           <a:p xmlns:a="http://schemas.openxmlformats.org/drawingml/2006/main">
             <a:r>
-              <a:t>Close with a conversation about their actual property or park. For park owners, show the lot, rent and shared-cost workflow and discuss the service needs. For homeowners, start with one relevant service. Confirm available crews, timing, scope and any applicable fees before an enrollment commitment. The next step is LakeLife.ai. Park inquiries are at https://www.lakelife.ai/for-parks.</a:t>
+              <a:t>Close with a conversation about their actual property or park. For park owners, show the lot, rent and shared-cost workflow and discuss the service needs. For homeowners, start with one relevant service. Review pricing status, scope and available crews. Some requests await a crew quote. A requested date is not a confirmed appointment. The next step is LakeLife.ai. Park inquiries are at https://www.lakelife.ai/for-parks.</a:t>
             </a:r>
           </a:p>
           <a:p xmlns:a="http://schemas.openxmlformats.org/drawingml/2006/main">
@@ -646,7 +646,7 @@
           <p:cNvPr id="3" name="Title">
             <a:extLst xmlns:a="http://schemas.openxmlformats.org/drawingml/2006/main">
               <a:ext uri="{FF2B5EF4-FFF2-40B4-BE49-F238E27FC236}">
-                <a16:creationId xmlns:a16="http://schemas.microsoft.com/office/drawing/2014/main" id="{DD0860B1-6E12-48BB-B40C-DC8694947C68}"/>
+                <a16:creationId xmlns:a16="http://schemas.microsoft.com/office/drawing/2014/main" id="{6202A60C-DD54-4E05-B0A2-EA4C3B91BC1D}"/>
               </a:ext>
             </a:extLst>
           </p:cNvPr>
@@ -803,7 +803,7 @@
           <p:cNvPr id="2" name="Subtitle">
             <a:extLst xmlns:a="http://schemas.openxmlformats.org/drawingml/2006/main">
               <a:ext uri="{FF2B5EF4-FFF2-40B4-BE49-F238E27FC236}">
-                <a16:creationId xmlns:a16="http://schemas.microsoft.com/office/drawing/2014/main" id="{2C72F1BE-508D-41DB-A2AE-41F924EAA71F}"/>
+                <a16:creationId xmlns:a16="http://schemas.microsoft.com/office/drawing/2014/main" id="{037620F9-C296-447B-BEE5-00022C1AE1B3}"/>
               </a:ext>
             </a:extLst>
           </p:cNvPr>
@@ -977,7 +977,7 @@
           <p:cNvPr id="2" name="Section title">
             <a:extLst xmlns:a="http://schemas.openxmlformats.org/drawingml/2006/main">
               <a:ext uri="{FF2B5EF4-FFF2-40B4-BE49-F238E27FC236}">
-                <a16:creationId xmlns:a16="http://schemas.microsoft.com/office/drawing/2014/main" id="{87002A8C-C62B-4AEA-B36C-57C1950B407E}"/>
+                <a16:creationId xmlns:a16="http://schemas.microsoft.com/office/drawing/2014/main" id="{1A3FF1AC-FA0D-4296-9B4F-5852C2AE9215}"/>
               </a:ext>
             </a:extLst>
           </p:cNvPr>
@@ -1151,7 +1151,7 @@
           <p:cNvPr id="3" name="Title">
             <a:extLst xmlns:a="http://schemas.openxmlformats.org/drawingml/2006/main">
               <a:ext uri="{FF2B5EF4-FFF2-40B4-BE49-F238E27FC236}">
-                <a16:creationId xmlns:a16="http://schemas.microsoft.com/office/drawing/2014/main" id="{8E500F1B-43D6-4F0B-B337-B7CCF971FA1C}"/>
+                <a16:creationId xmlns:a16="http://schemas.microsoft.com/office/drawing/2014/main" id="{627B0815-69E9-403A-B369-E2E1F41E746C}"/>
               </a:ext>
             </a:extLst>
           </p:cNvPr>
@@ -1308,7 +1308,7 @@
           <p:cNvPr id="2" name="Body">
             <a:extLst xmlns:a="http://schemas.openxmlformats.org/drawingml/2006/main">
               <a:ext uri="{FF2B5EF4-FFF2-40B4-BE49-F238E27FC236}">
-                <a16:creationId xmlns:a16="http://schemas.microsoft.com/office/drawing/2014/main" id="{0C20846D-F466-4F00-BE98-BE9DF5499099}"/>
+                <a16:creationId xmlns:a16="http://schemas.microsoft.com/office/drawing/2014/main" id="{02A2201F-5F83-44E4-BDC8-1EF1194DFE6A}"/>
               </a:ext>
             </a:extLst>
           </p:cNvPr>
@@ -1482,7 +1482,7 @@
           <p:cNvPr id="4" name="Title">
             <a:extLst xmlns:a="http://schemas.openxmlformats.org/drawingml/2006/main">
               <a:ext uri="{FF2B5EF4-FFF2-40B4-BE49-F238E27FC236}">
-                <a16:creationId xmlns:a16="http://schemas.microsoft.com/office/drawing/2014/main" id="{FA8910D0-6F15-4BBB-B9BD-B67BD4F53867}"/>
+                <a16:creationId xmlns:a16="http://schemas.microsoft.com/office/drawing/2014/main" id="{D4111654-E975-4F81-AF6D-D617666280A9}"/>
               </a:ext>
             </a:extLst>
           </p:cNvPr>
@@ -1639,7 +1639,7 @@
           <p:cNvPr id="2" name="Left column">
             <a:extLst xmlns:a="http://schemas.openxmlformats.org/drawingml/2006/main">
               <a:ext uri="{FF2B5EF4-FFF2-40B4-BE49-F238E27FC236}">
-                <a16:creationId xmlns:a16="http://schemas.microsoft.com/office/drawing/2014/main" id="{44B210FB-3423-46A2-80A1-C4DAB786DE2F}"/>
+                <a16:creationId xmlns:a16="http://schemas.microsoft.com/office/drawing/2014/main" id="{9D33232C-A880-4286-A8CC-EC3241030FDD}"/>
               </a:ext>
             </a:extLst>
           </p:cNvPr>
@@ -1796,7 +1796,7 @@
           <p:cNvPr id="3" name="Right column">
             <a:extLst xmlns:a="http://schemas.openxmlformats.org/drawingml/2006/main">
               <a:ext uri="{FF2B5EF4-FFF2-40B4-BE49-F238E27FC236}">
-                <a16:creationId xmlns:a16="http://schemas.microsoft.com/office/drawing/2014/main" id="{17B3179B-D505-4DCF-9C9E-CA69157AB382}"/>
+                <a16:creationId xmlns:a16="http://schemas.microsoft.com/office/drawing/2014/main" id="{AA0D08DA-B0B6-49B7-B8B2-2F0DDB16579E}"/>
               </a:ext>
             </a:extLst>
           </p:cNvPr>
@@ -1970,7 +1970,7 @@
           <p:cNvPr id="3" name="Title">
             <a:extLst xmlns:a="http://schemas.openxmlformats.org/drawingml/2006/main">
               <a:ext uri="{FF2B5EF4-FFF2-40B4-BE49-F238E27FC236}">
-                <a16:creationId xmlns:a16="http://schemas.microsoft.com/office/drawing/2014/main" id="{A0071868-B656-4934-AC9A-95066A06A4CE}"/>
+                <a16:creationId xmlns:a16="http://schemas.microsoft.com/office/drawing/2014/main" id="{C2529E11-0624-42F2-AA51-7D19F82934DE}"/>
               </a:ext>
             </a:extLst>
           </p:cNvPr>
@@ -2127,7 +2127,7 @@
           <p:cNvPr id="2" name="Left column">
             <a:extLst xmlns:a="http://schemas.openxmlformats.org/drawingml/2006/main">
               <a:ext uri="{FF2B5EF4-FFF2-40B4-BE49-F238E27FC236}">
-                <a16:creationId xmlns:a16="http://schemas.microsoft.com/office/drawing/2014/main" id="{32889D16-4CD5-4ECD-8C7B-984323C12FC9}"/>
+                <a16:creationId xmlns:a16="http://schemas.microsoft.com/office/drawing/2014/main" id="{5FAE2E9C-CC59-4DBD-86E9-8FDD6AC1A7AD}"/>
               </a:ext>
             </a:extLst>
           </p:cNvPr>
@@ -2322,12 +2322,12 @@
   </p:cSld>
   <p:clrMap bg1="lt1" tx1="dk1" bg2="lt2" tx2="dk2" accent1="accent1" accent2="accent2" accent3="accent3" accent4="accent4" accent5="accent5" accent6="accent6" hlink="hlink" folHlink="folHlink"/>
   <p:sldLayoutIdLst>
-    <p:sldLayoutId xmlns:r="http://schemas.openxmlformats.org/officeDocument/2006/relationships" id="2147483649" r:id="Ra6c1c6b6178c4959"/>
-    <p:sldLayoutId xmlns:r="http://schemas.openxmlformats.org/officeDocument/2006/relationships" id="2147483650" r:id="R33809a3638eb4bbc"/>
-    <p:sldLayoutId xmlns:r="http://schemas.openxmlformats.org/officeDocument/2006/relationships" id="2147483651" r:id="R030a48c552d64602"/>
-    <p:sldLayoutId xmlns:r="http://schemas.openxmlformats.org/officeDocument/2006/relationships" id="2147483652" r:id="R2b4327636c344331"/>
-    <p:sldLayoutId xmlns:r="http://schemas.openxmlformats.org/officeDocument/2006/relationships" id="2147483653" r:id="Rd32bf9b33f444cbe"/>
-    <p:sldLayoutId xmlns:r="http://schemas.openxmlformats.org/officeDocument/2006/relationships" id="2147483654" r:id="R1ffda30a33e24461"/>
+    <p:sldLayoutId xmlns:r="http://schemas.openxmlformats.org/officeDocument/2006/relationships" id="2147483649" r:id="R8e71929e2bbb4844"/>
+    <p:sldLayoutId xmlns:r="http://schemas.openxmlformats.org/officeDocument/2006/relationships" id="2147483650" r:id="Rfab5b8de6e104428"/>
+    <p:sldLayoutId xmlns:r="http://schemas.openxmlformats.org/officeDocument/2006/relationships" id="2147483651" r:id="R37c423090f40479e"/>
+    <p:sldLayoutId xmlns:r="http://schemas.openxmlformats.org/officeDocument/2006/relationships" id="2147483652" r:id="R7348dc8f1e3e486d"/>
+    <p:sldLayoutId xmlns:r="http://schemas.openxmlformats.org/officeDocument/2006/relationships" id="2147483653" r:id="Rdc435bfe96a14765"/>
+    <p:sldLayoutId xmlns:r="http://schemas.openxmlformats.org/officeDocument/2006/relationships" id="2147483654" r:id="R2ae1916b00624e26"/>
   </p:sldLayoutIdLst>
   <p:txStyles>
     <p:titleStyle>
@@ -2878,7 +2878,7 @@
           <p:cNvPr id="14" name="">
             <a:extLst xmlns:a="http://schemas.openxmlformats.org/drawingml/2006/main">
               <a:ext uri="{FF2B5EF4-FFF2-40B4-BE49-F238E27FC236}">
-                <a16:creationId xmlns:a16="http://schemas.microsoft.com/office/drawing/2014/main" id="{5BE5A420-08E7-4277-B425-2AA068B815BE}"/>
+                <a16:creationId xmlns:a16="http://schemas.microsoft.com/office/drawing/2014/main" id="{E29A6D46-00CF-4033-9E0A-EF7AB47FBCE9}"/>
               </a:ext>
             </a:extLst>
           </p:cNvPr>
@@ -2888,7 +2888,7 @@
           <p:nvPr/>
         </p:nvPicPr>
         <p:blipFill>
-          <a:blip xmlns:r="http://schemas.openxmlformats.org/officeDocument/2006/relationships" xmlns:a="http://schemas.openxmlformats.org/drawingml/2006/main" r:embed="Rfde212ea4aa74bd8"/>
+          <a:blip xmlns:r="http://schemas.openxmlformats.org/officeDocument/2006/relationships" xmlns:a="http://schemas.openxmlformats.org/drawingml/2006/main" r:embed="R86da0ec073d94e2b"/>
           <a:stretch xmlns:a="http://schemas.openxmlformats.org/drawingml/2006/main"/>
         </p:blipFill>
         <p:spPr>
@@ -2906,7 +2906,7 @@
           <p:cNvPr id="2" name="Lake">
             <a:extLst xmlns:a="http://schemas.openxmlformats.org/drawingml/2006/main">
               <a:ext uri="{FF2B5EF4-FFF2-40B4-BE49-F238E27FC236}">
-                <a16:creationId xmlns:a16="http://schemas.microsoft.com/office/drawing/2014/main" id="{E14D7978-A310-40A1-A669-DEF532E39AE1}"/>
+                <a16:creationId xmlns:a16="http://schemas.microsoft.com/office/drawing/2014/main" id="{CA7BAA09-D671-4D5D-AFBD-979810FA9A2A}"/>
               </a:ext>
             </a:extLst>
           </p:cNvPr>
@@ -2974,7 +2974,7 @@
           <p:cNvPr id="3" name="Life">
             <a:extLst xmlns:a="http://schemas.openxmlformats.org/drawingml/2006/main">
               <a:ext uri="{FF2B5EF4-FFF2-40B4-BE49-F238E27FC236}">
-                <a16:creationId xmlns:a16="http://schemas.microsoft.com/office/drawing/2014/main" id="{F01CEE65-02E4-4F08-86E7-E4016D3A7A74}"/>
+                <a16:creationId xmlns:a16="http://schemas.microsoft.com/office/drawing/2014/main" id="{BF653538-4F88-4D06-8989-C1B942F71301}"/>
               </a:ext>
             </a:extLst>
           </p:cNvPr>
@@ -3042,7 +3042,7 @@
           <p:cNvPr id="4" name="FOR MOBILE-HOME &amp; RV PARK OWNERS">
             <a:extLst xmlns:a="http://schemas.openxmlformats.org/drawingml/2006/main">
               <a:ext uri="{FF2B5EF4-FFF2-40B4-BE49-F238E27FC236}">
-                <a16:creationId xmlns:a16="http://schemas.microsoft.com/office/drawing/2014/main" id="{26AF25D1-0113-447E-B2D7-457D94017020}"/>
+                <a16:creationId xmlns:a16="http://schemas.microsoft.com/office/drawing/2014/main" id="{64247DDC-3E42-4B0C-AE04-B028F7C39676}"/>
               </a:ext>
             </a:extLst>
           </p:cNvPr>
@@ -3110,7 +3110,7 @@
           <p:cNvPr id="5" name="Your park,">
             <a:extLst xmlns:a="http://schemas.openxmlformats.org/drawingml/2006/main">
               <a:ext uri="{FF2B5EF4-FFF2-40B4-BE49-F238E27FC236}">
-                <a16:creationId xmlns:a16="http://schemas.microsoft.com/office/drawing/2014/main" id="{A72BC283-893F-4B21-82B7-C390125B1868}"/>
+                <a16:creationId xmlns:a16="http://schemas.microsoft.com/office/drawing/2014/main" id="{DE97FA1E-3062-4F79-83A9-C1B10212E70F}"/>
               </a:ext>
             </a:extLst>
           </p:cNvPr>
@@ -3178,7 +3178,7 @@
           <p:cNvPr id="6" name="in one place">
             <a:extLst xmlns:a="http://schemas.openxmlformats.org/drawingml/2006/main">
               <a:ext uri="{FF2B5EF4-FFF2-40B4-BE49-F238E27FC236}">
-                <a16:creationId xmlns:a16="http://schemas.microsoft.com/office/drawing/2014/main" id="{38DB9130-43C6-4E68-8A46-2DB8DBB2C2A9}"/>
+                <a16:creationId xmlns:a16="http://schemas.microsoft.com/office/drawing/2014/main" id="{DF16A1DA-1E45-444C-957A-FB5850A550AF}"/>
               </a:ext>
             </a:extLst>
           </p:cNvPr>
@@ -3246,7 +3246,7 @@
           <p:cNvPr id="7" name="Rent records, shared costs and crew work">
             <a:extLst xmlns:a="http://schemas.openxmlformats.org/drawingml/2006/main">
               <a:ext uri="{FF2B5EF4-FFF2-40B4-BE49-F238E27FC236}">
-                <a16:creationId xmlns:a16="http://schemas.microsoft.com/office/drawing/2014/main" id="{CEB45489-A186-447F-AB1D-06BDB8B8E776}"/>
+                <a16:creationId xmlns:a16="http://schemas.microsoft.com/office/drawing/2014/main" id="{F541F863-E1C6-481F-8051-A7D1747C9FD3}"/>
               </a:ext>
             </a:extLst>
           </p:cNvPr>
@@ -3314,7 +3314,7 @@
           <p:cNvPr id="8" name="A clearer view of what is owed and what ">
             <a:extLst xmlns:a="http://schemas.openxmlformats.org/drawingml/2006/main">
               <a:ext uri="{FF2B5EF4-FFF2-40B4-BE49-F238E27FC236}">
-                <a16:creationId xmlns:a16="http://schemas.microsoft.com/office/drawing/2014/main" id="{5E6D2991-C5D4-4C24-8758-BBBCE9C9E7B5}"/>
+                <a16:creationId xmlns:a16="http://schemas.microsoft.com/office/drawing/2014/main" id="{68407A60-FFBE-4C14-8FB4-E195DEB9B4EA}"/>
               </a:ext>
             </a:extLst>
           </p:cNvPr>
@@ -3382,7 +3382,7 @@
           <p:cNvPr id="9" name="">
             <a:extLst xmlns:a="http://schemas.openxmlformats.org/drawingml/2006/main">
               <a:ext uri="{FF2B5EF4-FFF2-40B4-BE49-F238E27FC236}">
-                <a16:creationId xmlns:a16="http://schemas.microsoft.com/office/drawing/2014/main" id="{7FC22B9E-A244-480F-A164-289B57528F37}"/>
+                <a16:creationId xmlns:a16="http://schemas.microsoft.com/office/drawing/2014/main" id="{B225B173-4162-49DC-B887-92B39A7AAA30}"/>
               </a:ext>
             </a:extLst>
           </p:cNvPr>
@@ -3392,7 +3392,7 @@
           <p:nvPr/>
         </p:nvPicPr>
         <p:blipFill>
-          <a:blip xmlns:r="http://schemas.openxmlformats.org/officeDocument/2006/relationships" xmlns:a="http://schemas.openxmlformats.org/drawingml/2006/main" r:embed="Re341e3cccb194079"/>
+          <a:blip xmlns:r="http://schemas.openxmlformats.org/officeDocument/2006/relationships" xmlns:a="http://schemas.openxmlformats.org/drawingml/2006/main" r:embed="Ra54c4f0775414587"/>
           <a:stretch xmlns:a="http://schemas.openxmlformats.org/drawingml/2006/main"/>
         </p:blipFill>
         <p:spPr>
@@ -3410,7 +3410,7 @@
           <p:cNvPr id="10" name="Scheduled bills by lot">
             <a:extLst xmlns:a="http://schemas.openxmlformats.org/drawingml/2006/main">
               <a:ext uri="{FF2B5EF4-FFF2-40B4-BE49-F238E27FC236}">
-                <a16:creationId xmlns:a16="http://schemas.microsoft.com/office/drawing/2014/main" id="{FFBB9DCD-16AA-4A14-9D81-5A1B504F21F3}"/>
+                <a16:creationId xmlns:a16="http://schemas.microsoft.com/office/drawing/2014/main" id="{4968C646-E21D-41F5-AFE9-4EBC1CB7FEC3}"/>
               </a:ext>
             </a:extLst>
           </p:cNvPr>
@@ -3478,7 +3478,7 @@
           <p:cNvPr id="11" name="Shared cost records">
             <a:extLst xmlns:a="http://schemas.openxmlformats.org/drawingml/2006/main">
               <a:ext uri="{FF2B5EF4-FFF2-40B4-BE49-F238E27FC236}">
-                <a16:creationId xmlns:a16="http://schemas.microsoft.com/office/drawing/2014/main" id="{CA952885-20FD-4657-81DF-930F4A08EF71}"/>
+                <a16:creationId xmlns:a16="http://schemas.microsoft.com/office/drawing/2014/main" id="{2019FB3B-5DE8-4261-B7BA-D076F2AAF8F3}"/>
               </a:ext>
             </a:extLst>
           </p:cNvPr>
@@ -3546,7 +3546,7 @@
           <p:cNvPr id="12" name="Work completion photos">
             <a:extLst xmlns:a="http://schemas.openxmlformats.org/drawingml/2006/main">
               <a:ext uri="{FF2B5EF4-FFF2-40B4-BE49-F238E27FC236}">
-                <a16:creationId xmlns:a16="http://schemas.microsoft.com/office/drawing/2014/main" id="{6BC581A9-548A-4D82-8370-88F6BE5B30E6}"/>
+                <a16:creationId xmlns:a16="http://schemas.microsoft.com/office/drawing/2014/main" id="{CF0D9308-95EA-42D9-9434-6CB7A0CEFB88}"/>
               </a:ext>
             </a:extLst>
           </p:cNvPr>
@@ -3614,7 +3614,7 @@
           <p:cNvPr id="13" name="">
             <a:extLst xmlns:a="http://schemas.openxmlformats.org/drawingml/2006/main">
               <a:ext uri="{FF2B5EF4-FFF2-40B4-BE49-F238E27FC236}">
-                <a16:creationId xmlns:a16="http://schemas.microsoft.com/office/drawing/2014/main" id="{45553A7C-6282-48DA-9D7D-0B8894163F3C}"/>
+                <a16:creationId xmlns:a16="http://schemas.microsoft.com/office/drawing/2014/main" id="{5263708E-C83B-461F-BBA0-068F99F2E16F}"/>
               </a:ext>
             </a:extLst>
           </p:cNvPr>
@@ -3624,7 +3624,7 @@
           <p:nvPr/>
         </p:nvPicPr>
         <p:blipFill>
-          <a:blip xmlns:r="http://schemas.openxmlformats.org/officeDocument/2006/relationships" xmlns:a="http://schemas.openxmlformats.org/drawingml/2006/main" r:embed="R7a8eb2794c2a48a7"/>
+          <a:blip xmlns:r="http://schemas.openxmlformats.org/officeDocument/2006/relationships" xmlns:a="http://schemas.openxmlformats.org/drawingml/2006/main" r:embed="R6afea8893ea04ad8"/>
           <a:stretch xmlns:a="http://schemas.openxmlformats.org/drawingml/2006/main"/>
         </p:blipFill>
         <p:spPr>
@@ -3640,7 +3640,7 @@
     </p:spTree>
     <p:extLst>
       <p:ext uri="{BB962C8B-B14F-4D97-AF65-F5344CB8AC3E}">
-        <p14:creationId xmlns:p14="http://schemas.microsoft.com/office/powerpoint/2010/main" val="1173666005"/>
+        <p14:creationId xmlns:p14="http://schemas.microsoft.com/office/powerpoint/2010/main" val="768288075"/>
       </p:ext>
     </p:extLst>
   </p:cSld>
@@ -3671,7 +3671,7 @@
           <p:cNvPr id="25" name="Dark brand band">
             <a:extLst xmlns:a="http://schemas.openxmlformats.org/drawingml/2006/main">
               <a:ext uri="{FF2B5EF4-FFF2-40B4-BE49-F238E27FC236}">
-                <a16:creationId xmlns:a16="http://schemas.microsoft.com/office/drawing/2014/main" id="{253C4C89-6B70-4C56-906B-4AE64F8EE5F8}"/>
+                <a16:creationId xmlns:a16="http://schemas.microsoft.com/office/drawing/2014/main" id="{70BD63C3-E12F-4FBF-A96B-29EA4E5BE5AA}"/>
               </a:ext>
             </a:extLst>
           </p:cNvPr>
@@ -3701,7 +3701,7 @@
           <p:cNvPr id="2" name="">
             <a:extLst xmlns:a="http://schemas.openxmlformats.org/drawingml/2006/main">
               <a:ext uri="{FF2B5EF4-FFF2-40B4-BE49-F238E27FC236}">
-                <a16:creationId xmlns:a16="http://schemas.microsoft.com/office/drawing/2014/main" id="{70D31060-0F93-462F-90BC-FB685B71B9DC}"/>
+                <a16:creationId xmlns:a16="http://schemas.microsoft.com/office/drawing/2014/main" id="{55243CB6-F0AF-4027-AF6C-5788A9193071}"/>
               </a:ext>
             </a:extLst>
           </p:cNvPr>
@@ -3711,7 +3711,7 @@
           <p:nvPr/>
         </p:nvPicPr>
         <p:blipFill>
-          <a:blip xmlns:r="http://schemas.openxmlformats.org/officeDocument/2006/relationships" xmlns:a="http://schemas.openxmlformats.org/drawingml/2006/main" r:embed="R8c594124f34c4f41"/>
+          <a:blip xmlns:r="http://schemas.openxmlformats.org/officeDocument/2006/relationships" xmlns:a="http://schemas.openxmlformats.org/drawingml/2006/main" r:embed="R16c16ff868c1407c"/>
           <a:stretch xmlns:a="http://schemas.openxmlformats.org/drawingml/2006/main"/>
         </p:blipFill>
         <p:spPr>
@@ -3729,7 +3729,7 @@
           <p:cNvPr id="3" name="Lake">
             <a:extLst xmlns:a="http://schemas.openxmlformats.org/drawingml/2006/main">
               <a:ext uri="{FF2B5EF4-FFF2-40B4-BE49-F238E27FC236}">
-                <a16:creationId xmlns:a16="http://schemas.microsoft.com/office/drawing/2014/main" id="{DE6F6D90-7020-4834-BC03-6CD08AF7D64C}"/>
+                <a16:creationId xmlns:a16="http://schemas.microsoft.com/office/drawing/2014/main" id="{C3649251-44CF-4523-AF2C-426515C99F08}"/>
               </a:ext>
             </a:extLst>
           </p:cNvPr>
@@ -3797,7 +3797,7 @@
           <p:cNvPr id="4" name="Life">
             <a:extLst xmlns:a="http://schemas.openxmlformats.org/drawingml/2006/main">
               <a:ext uri="{FF2B5EF4-FFF2-40B4-BE49-F238E27FC236}">
-                <a16:creationId xmlns:a16="http://schemas.microsoft.com/office/drawing/2014/main" id="{33FFCE9D-93B0-4655-A115-C528DEAA3386}"/>
+                <a16:creationId xmlns:a16="http://schemas.microsoft.com/office/drawing/2014/main" id="{39152262-0C6D-4672-A302-2E9CD42F1243}"/>
               </a:ext>
             </a:extLst>
           </p:cNvPr>
@@ -3865,7 +3865,7 @@
           <p:cNvPr id="5" name="FOR LAKE HOMEOWNERS">
             <a:extLst xmlns:a="http://schemas.openxmlformats.org/drawingml/2006/main">
               <a:ext uri="{FF2B5EF4-FFF2-40B4-BE49-F238E27FC236}">
-                <a16:creationId xmlns:a16="http://schemas.microsoft.com/office/drawing/2014/main" id="{584762D4-61F8-4815-A9C8-3CBAB13309F3}"/>
+                <a16:creationId xmlns:a16="http://schemas.microsoft.com/office/drawing/2014/main" id="{85C4B677-FFC8-4FD7-B6E4-3B86AD399654}"/>
               </a:ext>
             </a:extLst>
           </p:cNvPr>
@@ -3933,7 +3933,7 @@
           <p:cNvPr id="6" name="Your lake house,">
             <a:extLst xmlns:a="http://schemas.openxmlformats.org/drawingml/2006/main">
               <a:ext uri="{FF2B5EF4-FFF2-40B4-BE49-F238E27FC236}">
-                <a16:creationId xmlns:a16="http://schemas.microsoft.com/office/drawing/2014/main" id="{0A366DC2-A485-458E-B57B-A375E42D3C70}"/>
+                <a16:creationId xmlns:a16="http://schemas.microsoft.com/office/drawing/2014/main" id="{2D2486CC-EB13-421B-AE74-AF041046F55C}"/>
               </a:ext>
             </a:extLst>
           </p:cNvPr>
@@ -4001,7 +4001,7 @@
           <p:cNvPr id="7" name="ready when you are">
             <a:extLst xmlns:a="http://schemas.openxmlformats.org/drawingml/2006/main">
               <a:ext uri="{FF2B5EF4-FFF2-40B4-BE49-F238E27FC236}">
-                <a16:creationId xmlns:a16="http://schemas.microsoft.com/office/drawing/2014/main" id="{5CC72A83-27D6-488B-9566-AAB42F0B85F0}"/>
+                <a16:creationId xmlns:a16="http://schemas.microsoft.com/office/drawing/2014/main" id="{2FEC6458-FEF9-4FF3-B43B-4210EF1BB2E8}"/>
               </a:ext>
             </a:extLst>
           </p:cNvPr>
@@ -4066,10 +4066,10 @@
       </p:sp>
       <p:sp>
         <p:nvSpPr>
-          <p:cNvPr id="8" name="One clear service price">
+          <p:cNvPr id="8" name="Know the pricing status">
             <a:extLst xmlns:a="http://schemas.openxmlformats.org/drawingml/2006/main">
               <a:ext uri="{FF2B5EF4-FFF2-40B4-BE49-F238E27FC236}">
-                <a16:creationId xmlns:a16="http://schemas.microsoft.com/office/drawing/2014/main" id="{F57DF065-46F9-412B-A041-00838D4DD2EC}"/>
+                <a16:creationId xmlns:a16="http://schemas.microsoft.com/office/drawing/2014/main" id="{13D5E216-915E-4633-B8AA-25FEF79B828C}"/>
               </a:ext>
             </a:extLst>
           </p:cNvPr>
@@ -4127,17 +4127,17 @@
                 <a:ea typeface="Manrope"/>
                 <a:cs typeface="Manrope"/>
               </a:rPr>
-              <a:t>One clear service price</a:t>
+              <a:t>Know the pricing status</a:t>
             </a:r>
           </a:p>
         </p:txBody>
       </p:sp>
       <p:sp>
         <p:nvSpPr>
-          <p:cNvPr id="9" name="Review the total before&#10;you book.">
+          <p:cNvPr id="9" name="See the price before&#10;anything is charged">
             <a:extLst xmlns:a="http://schemas.openxmlformats.org/drawingml/2006/main">
               <a:ext uri="{FF2B5EF4-FFF2-40B4-BE49-F238E27FC236}">
-                <a16:creationId xmlns:a16="http://schemas.microsoft.com/office/drawing/2014/main" id="{7DF0B19A-290F-482F-B21E-FD367FE8E4B8}"/>
+                <a16:creationId xmlns:a16="http://schemas.microsoft.com/office/drawing/2014/main" id="{F944A230-CA85-4D7B-A359-90D91759831D}"/>
               </a:ext>
             </a:extLst>
           </p:cNvPr>
@@ -4195,7 +4195,7 @@
                 <a:ea typeface="Manrope"/>
                 <a:cs typeface="Manrope"/>
               </a:rPr>
-              <a:t>Review the total before</a:t>
+              <a:t>See the price before</a:t>
             </a:r>
           </a:p>
           <a:p xmlns:a="http://schemas.openxmlformats.org/drawingml/2006/main">
@@ -4218,7 +4218,7 @@
                 <a:ea typeface="Manrope"/>
                 <a:cs typeface="Manrope"/>
               </a:rPr>
-              <a:t>you book.</a:t>
+              <a:t>anything is charged.</a:t>
             </a:r>
           </a:p>
         </p:txBody>
@@ -4228,7 +4228,7 @@
           <p:cNvPr id="10" name="Photos of finished work">
             <a:extLst xmlns:a="http://schemas.openxmlformats.org/drawingml/2006/main">
               <a:ext uri="{FF2B5EF4-FFF2-40B4-BE49-F238E27FC236}">
-                <a16:creationId xmlns:a16="http://schemas.microsoft.com/office/drawing/2014/main" id="{8EDF0D5A-ACDB-4740-B1BD-CE85EC4A5F5A}"/>
+                <a16:creationId xmlns:a16="http://schemas.microsoft.com/office/drawing/2014/main" id="{7E90894E-D709-4E0A-A823-5368D86D5542}"/>
               </a:ext>
             </a:extLst>
           </p:cNvPr>
@@ -4296,7 +4296,7 @@
           <p:cNvPr id="11" name="See the work in your&#10;property record.">
             <a:extLst xmlns:a="http://schemas.openxmlformats.org/drawingml/2006/main">
               <a:ext uri="{FF2B5EF4-FFF2-40B4-BE49-F238E27FC236}">
-                <a16:creationId xmlns:a16="http://schemas.microsoft.com/office/drawing/2014/main" id="{DD6528AF-FB89-4901-A0C2-8FAB4973C76A}"/>
+                <a16:creationId xmlns:a16="http://schemas.microsoft.com/office/drawing/2014/main" id="{8B2B2A6A-DF23-4FEC-AFBE-2D84C422F9D0}"/>
               </a:ext>
             </a:extLst>
           </p:cNvPr>
@@ -4384,10 +4384,10 @@
       </p:sp>
       <p:sp>
         <p:nvSpPr>
-          <p:cNvPr id="12" name="You approve changes">
+          <p:cNvPr id="12" name="You review corrections">
             <a:extLst xmlns:a="http://schemas.openxmlformats.org/drawingml/2006/main">
               <a:ext uri="{FF2B5EF4-FFF2-40B4-BE49-F238E27FC236}">
-                <a16:creationId xmlns:a16="http://schemas.microsoft.com/office/drawing/2014/main" id="{3102EC07-7F45-4462-AF1A-F62F3DA77EDC}"/>
+                <a16:creationId xmlns:a16="http://schemas.microsoft.com/office/drawing/2014/main" id="{05D7F9B6-A27D-40A9-BCC4-596BF3477019}"/>
               </a:ext>
             </a:extLst>
           </p:cNvPr>
@@ -4445,17 +4445,17 @@
                 <a:ea typeface="Manrope"/>
                 <a:cs typeface="Manrope"/>
               </a:rPr>
-              <a:t>You approve changes</a:t>
+              <a:t>You review corrections</a:t>
             </a:r>
           </a:p>
         </p:txBody>
       </p:sp>
       <p:sp>
         <p:nvSpPr>
-          <p:cNvPr id="13" name="Approve proposed changes&#10;before they aff">
+          <p:cNvPr id="13" name="Approve profile changes&#10;before they affe">
             <a:extLst xmlns:a="http://schemas.openxmlformats.org/drawingml/2006/main">
               <a:ext uri="{FF2B5EF4-FFF2-40B4-BE49-F238E27FC236}">
-                <a16:creationId xmlns:a16="http://schemas.microsoft.com/office/drawing/2014/main" id="{C3C8CEC7-5291-49D7-BA2E-1239C8FC41DD}"/>
+                <a16:creationId xmlns:a16="http://schemas.microsoft.com/office/drawing/2014/main" id="{B8EEE28B-2502-4C60-9953-56F4EA1BA870}"/>
               </a:ext>
             </a:extLst>
           </p:cNvPr>
@@ -4513,7 +4513,7 @@
                 <a:ea typeface="Manrope"/>
                 <a:cs typeface="Manrope"/>
               </a:rPr>
-              <a:t>Approve proposed changes</a:t>
+              <a:t>Approve profile changes</a:t>
             </a:r>
           </a:p>
           <a:p xmlns:a="http://schemas.openxmlformats.org/drawingml/2006/main">
@@ -4546,7 +4546,7 @@
           <p:cNvPr id="14" name="">
             <a:extLst xmlns:a="http://schemas.openxmlformats.org/drawingml/2006/main">
               <a:ext uri="{FF2B5EF4-FFF2-40B4-BE49-F238E27FC236}">
-                <a16:creationId xmlns:a16="http://schemas.microsoft.com/office/drawing/2014/main" id="{6070B776-3183-4645-83DA-E942FD9ED907}"/>
+                <a16:creationId xmlns:a16="http://schemas.microsoft.com/office/drawing/2014/main" id="{A5F7AD92-842A-459E-9901-61F1F6C58E02}"/>
               </a:ext>
             </a:extLst>
           </p:cNvPr>
@@ -4556,7 +4556,7 @@
           <p:nvPr/>
         </p:nvPicPr>
         <p:blipFill>
-          <a:blip xmlns:r="http://schemas.openxmlformats.org/officeDocument/2006/relationships" xmlns:a="http://schemas.openxmlformats.org/drawingml/2006/main" r:embed="R63e435b182374605"/>
+          <a:blip xmlns:r="http://schemas.openxmlformats.org/officeDocument/2006/relationships" xmlns:a="http://schemas.openxmlformats.org/drawingml/2006/main" r:embed="R36eddeb0d4084591"/>
           <a:stretch xmlns:a="http://schemas.openxmlformats.org/drawingml/2006/main"/>
         </p:blipFill>
         <p:spPr>
@@ -4574,7 +4574,7 @@
           <p:cNvPr id="15" name="Opening &amp; closing">
             <a:extLst xmlns:a="http://schemas.openxmlformats.org/drawingml/2006/main">
               <a:ext uri="{FF2B5EF4-FFF2-40B4-BE49-F238E27FC236}">
-                <a16:creationId xmlns:a16="http://schemas.microsoft.com/office/drawing/2014/main" id="{0DB52B64-12D5-4254-8DFF-817A32006AE1}"/>
+                <a16:creationId xmlns:a16="http://schemas.microsoft.com/office/drawing/2014/main" id="{D7937F37-CF1E-4C04-A7A0-56F4FE1BEC08}"/>
               </a:ext>
             </a:extLst>
           </p:cNvPr>
@@ -4642,7 +4642,7 @@
           <p:cNvPr id="16" name="">
             <a:extLst xmlns:a="http://schemas.openxmlformats.org/drawingml/2006/main">
               <a:ext uri="{FF2B5EF4-FFF2-40B4-BE49-F238E27FC236}">
-                <a16:creationId xmlns:a16="http://schemas.microsoft.com/office/drawing/2014/main" id="{AAA32D78-5721-4725-8BF8-1950D472D653}"/>
+                <a16:creationId xmlns:a16="http://schemas.microsoft.com/office/drawing/2014/main" id="{AF6EE55F-1BDF-41ED-93D9-1157CCA84512}"/>
               </a:ext>
             </a:extLst>
           </p:cNvPr>
@@ -4652,7 +4652,7 @@
           <p:nvPr/>
         </p:nvPicPr>
         <p:blipFill>
-          <a:blip xmlns:r="http://schemas.openxmlformats.org/officeDocument/2006/relationships" xmlns:a="http://schemas.openxmlformats.org/drawingml/2006/main" r:embed="Ra613915e23c241dc"/>
+          <a:blip xmlns:r="http://schemas.openxmlformats.org/officeDocument/2006/relationships" xmlns:a="http://schemas.openxmlformats.org/drawingml/2006/main" r:embed="R75637e379d2047da"/>
           <a:stretch xmlns:a="http://schemas.openxmlformats.org/drawingml/2006/main"/>
         </p:blipFill>
         <p:spPr>
@@ -4670,7 +4670,7 @@
           <p:cNvPr id="17" name="Piers &amp; lifts">
             <a:extLst xmlns:a="http://schemas.openxmlformats.org/drawingml/2006/main">
               <a:ext uri="{FF2B5EF4-FFF2-40B4-BE49-F238E27FC236}">
-                <a16:creationId xmlns:a16="http://schemas.microsoft.com/office/drawing/2014/main" id="{C4755FDC-EC60-401F-BAA5-CF40B8C18E9D}"/>
+                <a16:creationId xmlns:a16="http://schemas.microsoft.com/office/drawing/2014/main" id="{88D0C709-7AE1-4A93-9C92-324844AC35F0}"/>
               </a:ext>
             </a:extLst>
           </p:cNvPr>
@@ -4738,7 +4738,7 @@
           <p:cNvPr id="18" name="">
             <a:extLst xmlns:a="http://schemas.openxmlformats.org/drawingml/2006/main">
               <a:ext uri="{FF2B5EF4-FFF2-40B4-BE49-F238E27FC236}">
-                <a16:creationId xmlns:a16="http://schemas.microsoft.com/office/drawing/2014/main" id="{0D5B81DD-805A-4480-A59A-9ECF0CCA8627}"/>
+                <a16:creationId xmlns:a16="http://schemas.microsoft.com/office/drawing/2014/main" id="{37AF9F36-DAC6-42A9-9E86-5E24629687A3}"/>
               </a:ext>
             </a:extLst>
           </p:cNvPr>
@@ -4748,7 +4748,7 @@
           <p:nvPr/>
         </p:nvPicPr>
         <p:blipFill>
-          <a:blip xmlns:r="http://schemas.openxmlformats.org/officeDocument/2006/relationships" xmlns:a="http://schemas.openxmlformats.org/drawingml/2006/main" r:embed="R33b953b5c35a4bb1"/>
+          <a:blip xmlns:r="http://schemas.openxmlformats.org/officeDocument/2006/relationships" xmlns:a="http://schemas.openxmlformats.org/drawingml/2006/main" r:embed="R5e74fc84b50c4b57"/>
           <a:stretch xmlns:a="http://schemas.openxmlformats.org/drawingml/2006/main"/>
         </p:blipFill>
         <p:spPr>
@@ -4766,7 +4766,7 @@
           <p:cNvPr id="19" name="Boat care &amp; storage">
             <a:extLst xmlns:a="http://schemas.openxmlformats.org/drawingml/2006/main">
               <a:ext uri="{FF2B5EF4-FFF2-40B4-BE49-F238E27FC236}">
-                <a16:creationId xmlns:a16="http://schemas.microsoft.com/office/drawing/2014/main" id="{D2B2F6E7-538C-4D58-A121-41E5A5D8F4D0}"/>
+                <a16:creationId xmlns:a16="http://schemas.microsoft.com/office/drawing/2014/main" id="{E84A3E28-C0F4-466E-AE37-621CF430DA93}"/>
               </a:ext>
             </a:extLst>
           </p:cNvPr>
@@ -4834,7 +4834,7 @@
           <p:cNvPr id="20" name="">
             <a:extLst xmlns:a="http://schemas.openxmlformats.org/drawingml/2006/main">
               <a:ext uri="{FF2B5EF4-FFF2-40B4-BE49-F238E27FC236}">
-                <a16:creationId xmlns:a16="http://schemas.microsoft.com/office/drawing/2014/main" id="{D1EF76C4-8EB2-477D-A587-B15DE0D43E90}"/>
+                <a16:creationId xmlns:a16="http://schemas.microsoft.com/office/drawing/2014/main" id="{FA9B5368-E3CC-4BBB-97BE-087991727919}"/>
               </a:ext>
             </a:extLst>
           </p:cNvPr>
@@ -4844,7 +4844,7 @@
           <p:nvPr/>
         </p:nvPicPr>
         <p:blipFill>
-          <a:blip xmlns:r="http://schemas.openxmlformats.org/officeDocument/2006/relationships" xmlns:a="http://schemas.openxmlformats.org/drawingml/2006/main" r:embed="R57b0bb771a554fbe"/>
+          <a:blip xmlns:r="http://schemas.openxmlformats.org/officeDocument/2006/relationships" xmlns:a="http://schemas.openxmlformats.org/drawingml/2006/main" r:embed="Rebc2d5c57c2f4ea8"/>
           <a:stretch xmlns:a="http://schemas.openxmlformats.org/drawingml/2006/main"/>
         </p:blipFill>
         <p:spPr>
@@ -4862,7 +4862,7 @@
           <p:cNvPr id="21" name="Lawn care">
             <a:extLst xmlns:a="http://schemas.openxmlformats.org/drawingml/2006/main">
               <a:ext uri="{FF2B5EF4-FFF2-40B4-BE49-F238E27FC236}">
-                <a16:creationId xmlns:a16="http://schemas.microsoft.com/office/drawing/2014/main" id="{B7330A33-D1E4-4C55-ABDD-F7262BD42B27}"/>
+                <a16:creationId xmlns:a16="http://schemas.microsoft.com/office/drawing/2014/main" id="{8CB3505D-501A-4B56-BC4B-2F748A06BA68}"/>
               </a:ext>
             </a:extLst>
           </p:cNvPr>
@@ -4930,7 +4930,7 @@
           <p:cNvPr id="22" name="">
             <a:extLst xmlns:a="http://schemas.openxmlformats.org/drawingml/2006/main">
               <a:ext uri="{FF2B5EF4-FFF2-40B4-BE49-F238E27FC236}">
-                <a16:creationId xmlns:a16="http://schemas.microsoft.com/office/drawing/2014/main" id="{9F1F26DA-9362-4011-A3CE-102FC39BDC87}"/>
+                <a16:creationId xmlns:a16="http://schemas.microsoft.com/office/drawing/2014/main" id="{9207FD89-657A-4633-AB35-49A379B9521F}"/>
               </a:ext>
             </a:extLst>
           </p:cNvPr>
@@ -4940,7 +4940,7 @@
           <p:nvPr/>
         </p:nvPicPr>
         <p:blipFill>
-          <a:blip xmlns:r="http://schemas.openxmlformats.org/officeDocument/2006/relationships" xmlns:a="http://schemas.openxmlformats.org/drawingml/2006/main" r:embed="R99a8b7f9d38a4f9d"/>
+          <a:blip xmlns:r="http://schemas.openxmlformats.org/officeDocument/2006/relationships" xmlns:a="http://schemas.openxmlformats.org/drawingml/2006/main" r:embed="Rab33a60b37ab481e"/>
           <a:stretch xmlns:a="http://schemas.openxmlformats.org/drawingml/2006/main"/>
         </p:blipFill>
         <p:spPr>
@@ -4958,7 +4958,7 @@
           <p:cNvPr id="23" name="Housekeeping">
             <a:extLst xmlns:a="http://schemas.openxmlformats.org/drawingml/2006/main">
               <a:ext uri="{FF2B5EF4-FFF2-40B4-BE49-F238E27FC236}">
-                <a16:creationId xmlns:a16="http://schemas.microsoft.com/office/drawing/2014/main" id="{03126355-24B7-4FF2-A978-2344F5983F92}"/>
+                <a16:creationId xmlns:a16="http://schemas.microsoft.com/office/drawing/2014/main" id="{3EDA4B55-9147-4B04-8C71-185E0F5F8EED}"/>
               </a:ext>
             </a:extLst>
           </p:cNvPr>
@@ -5023,10 +5023,10 @@
       </p:sp>
       <p:sp>
         <p:nvSpPr>
-          <p:cNvPr id="24" name="Big Long, Pretty and Big Turkey Lakes, I">
+          <p:cNvPr id="24" name="Big Long, Pretty &amp; Big Turkey Lakes · Av">
             <a:extLst xmlns:a="http://schemas.openxmlformats.org/drawingml/2006/main">
               <a:ext uri="{FF2B5EF4-FFF2-40B4-BE49-F238E27FC236}">
-                <a16:creationId xmlns:a16="http://schemas.microsoft.com/office/drawing/2014/main" id="{EBE4BC15-4304-4E1B-9604-42784B4656BE}"/>
+                <a16:creationId xmlns:a16="http://schemas.microsoft.com/office/drawing/2014/main" id="{5073004D-8BFD-4FE8-B542-F61F7DC2D004}"/>
               </a:ext>
             </a:extLst>
           </p:cNvPr>
@@ -5084,7 +5084,7 @@
                 <a:ea typeface="Manrope"/>
                 <a:cs typeface="Manrope"/>
               </a:rPr>
-              <a:t>Big Long, Pretty and Big Turkey Lakes, Indiana</a:t>
+              <a:t>Big Long, Pretty &amp; Big Turkey Lakes · Availability varies; some requests await a crew quote.</a:t>
             </a:r>
           </a:p>
         </p:txBody>
@@ -5092,7 +5092,7 @@
     </p:spTree>
     <p:extLst>
       <p:ext uri="{BB962C8B-B14F-4D97-AF65-F5344CB8AC3E}">
-        <p14:creationId xmlns:p14="http://schemas.microsoft.com/office/powerpoint/2010/main" val="1092942661"/>
+        <p14:creationId xmlns:p14="http://schemas.microsoft.com/office/powerpoint/2010/main" val="1835838823"/>
       </p:ext>
     </p:extLst>
   </p:cSld>
@@ -5123,7 +5123,7 @@
           <p:cNvPr id="15" name="">
             <a:extLst xmlns:a="http://schemas.openxmlformats.org/drawingml/2006/main">
               <a:ext uri="{FF2B5EF4-FFF2-40B4-BE49-F238E27FC236}">
-                <a16:creationId xmlns:a16="http://schemas.microsoft.com/office/drawing/2014/main" id="{ED147A20-338E-4EBC-87BD-5C584E02FD08}"/>
+                <a16:creationId xmlns:a16="http://schemas.microsoft.com/office/drawing/2014/main" id="{065D0A3F-3649-4AA5-BF4B-4207AF82F9D1}"/>
               </a:ext>
             </a:extLst>
           </p:cNvPr>
@@ -5133,7 +5133,7 @@
           <p:nvPr/>
         </p:nvPicPr>
         <p:blipFill>
-          <a:blip xmlns:r="http://schemas.openxmlformats.org/officeDocument/2006/relationships" xmlns:a="http://schemas.openxmlformats.org/drawingml/2006/main" r:embed="R0eec8b7642614643"/>
+          <a:blip xmlns:r="http://schemas.openxmlformats.org/officeDocument/2006/relationships" xmlns:a="http://schemas.openxmlformats.org/drawingml/2006/main" r:embed="R74686c9aacfa4a78"/>
           <a:stretch xmlns:a="http://schemas.openxmlformats.org/drawingml/2006/main"/>
         </p:blipFill>
         <p:spPr>
@@ -5151,7 +5151,7 @@
           <p:cNvPr id="2" name="Lake">
             <a:extLst xmlns:a="http://schemas.openxmlformats.org/drawingml/2006/main">
               <a:ext uri="{FF2B5EF4-FFF2-40B4-BE49-F238E27FC236}">
-                <a16:creationId xmlns:a16="http://schemas.microsoft.com/office/drawing/2014/main" id="{CE416AB6-B816-411A-986B-E9F92C34AE86}"/>
+                <a16:creationId xmlns:a16="http://schemas.microsoft.com/office/drawing/2014/main" id="{EB9C3470-2E77-4B17-8928-7315085D86AE}"/>
               </a:ext>
             </a:extLst>
           </p:cNvPr>
@@ -5219,7 +5219,7 @@
           <p:cNvPr id="3" name="Life">
             <a:extLst xmlns:a="http://schemas.openxmlformats.org/drawingml/2006/main">
               <a:ext uri="{FF2B5EF4-FFF2-40B4-BE49-F238E27FC236}">
-                <a16:creationId xmlns:a16="http://schemas.microsoft.com/office/drawing/2014/main" id="{CB265375-BB6A-4A85-B21E-078B63FC6B33}"/>
+                <a16:creationId xmlns:a16="http://schemas.microsoft.com/office/drawing/2014/main" id="{F4B2CDD6-DD5E-4725-A073-CFF18F058A38}"/>
               </a:ext>
             </a:extLst>
           </p:cNvPr>
@@ -5287,7 +5287,7 @@
           <p:cNvPr id="4" name="See LakeLife at work">
             <a:extLst xmlns:a="http://schemas.openxmlformats.org/drawingml/2006/main">
               <a:ext uri="{FF2B5EF4-FFF2-40B4-BE49-F238E27FC236}">
-                <a16:creationId xmlns:a16="http://schemas.microsoft.com/office/drawing/2014/main" id="{4B8A8644-0A4D-40E8-A190-B80AEAC42DEB}"/>
+                <a16:creationId xmlns:a16="http://schemas.microsoft.com/office/drawing/2014/main" id="{FD758378-5346-44CA-B921-D7B239797B31}"/>
               </a:ext>
             </a:extLst>
           </p:cNvPr>
@@ -5355,7 +5355,7 @@
           <p:cNvPr id="5" name="Start with what takes the most chasing.">
             <a:extLst xmlns:a="http://schemas.openxmlformats.org/drawingml/2006/main">
               <a:ext uri="{FF2B5EF4-FFF2-40B4-BE49-F238E27FC236}">
-                <a16:creationId xmlns:a16="http://schemas.microsoft.com/office/drawing/2014/main" id="{E0DE95C2-5248-4AE3-A5CB-B02E31360C7E}"/>
+                <a16:creationId xmlns:a16="http://schemas.microsoft.com/office/drawing/2014/main" id="{5032B348-F75E-4768-BAEF-1483D51442AF}"/>
               </a:ext>
             </a:extLst>
           </p:cNvPr>
@@ -5423,7 +5423,7 @@
           <p:cNvPr id="6" name="PARK OWNERS">
             <a:extLst xmlns:a="http://schemas.openxmlformats.org/drawingml/2006/main">
               <a:ext uri="{FF2B5EF4-FFF2-40B4-BE49-F238E27FC236}">
-                <a16:creationId xmlns:a16="http://schemas.microsoft.com/office/drawing/2014/main" id="{628110C2-FAF8-4EFC-8F8A-7AD65419D38E}"/>
+                <a16:creationId xmlns:a16="http://schemas.microsoft.com/office/drawing/2014/main" id="{DE38CFE1-072F-4A65-8DD4-AD756C8354E7}"/>
               </a:ext>
             </a:extLst>
           </p:cNvPr>
@@ -5491,7 +5491,7 @@
           <p:cNvPr id="7" name="Ask for a walkthrough">
             <a:extLst xmlns:a="http://schemas.openxmlformats.org/drawingml/2006/main">
               <a:ext uri="{FF2B5EF4-FFF2-40B4-BE49-F238E27FC236}">
-                <a16:creationId xmlns:a16="http://schemas.microsoft.com/office/drawing/2014/main" id="{40386650-99AE-4DC0-8E2A-B043FFAB0BB2}"/>
+                <a16:creationId xmlns:a16="http://schemas.microsoft.com/office/drawing/2014/main" id="{04254D91-9EA8-4DCA-BFC9-9E7F9C04136A}"/>
               </a:ext>
             </a:extLst>
           </p:cNvPr>
@@ -5559,7 +5559,7 @@
           <p:cNvPr id="8" name="Tell us about your lots and the work&#10;you">
             <a:extLst xmlns:a="http://schemas.openxmlformats.org/drawingml/2006/main">
               <a:ext uri="{FF2B5EF4-FFF2-40B4-BE49-F238E27FC236}">
-                <a16:creationId xmlns:a16="http://schemas.microsoft.com/office/drawing/2014/main" id="{A45610C6-A302-4071-B44E-4B292883AA72}"/>
+                <a16:creationId xmlns:a16="http://schemas.microsoft.com/office/drawing/2014/main" id="{EAC79B9F-A9CC-407C-95D4-68DC228D1FDC}"/>
               </a:ext>
             </a:extLst>
           </p:cNvPr>
@@ -5650,7 +5650,7 @@
           <p:cNvPr id="9" name="HOMEOWNERS">
             <a:extLst xmlns:a="http://schemas.openxmlformats.org/drawingml/2006/main">
               <a:ext uri="{FF2B5EF4-FFF2-40B4-BE49-F238E27FC236}">
-                <a16:creationId xmlns:a16="http://schemas.microsoft.com/office/drawing/2014/main" id="{265EFCDC-EBF6-41DF-9649-7EC7D8113E00}"/>
+                <a16:creationId xmlns:a16="http://schemas.microsoft.com/office/drawing/2014/main" id="{39E49BC6-9881-4760-9803-009161E8715B}"/>
               </a:ext>
             </a:extLst>
           </p:cNvPr>
@@ -5718,7 +5718,7 @@
           <p:cNvPr id="10" name="Choose your first service">
             <a:extLst xmlns:a="http://schemas.openxmlformats.org/drawingml/2006/main">
               <a:ext uri="{FF2B5EF4-FFF2-40B4-BE49-F238E27FC236}">
-                <a16:creationId xmlns:a16="http://schemas.microsoft.com/office/drawing/2014/main" id="{6E52EF5A-25D2-416A-8B75-A4243837E50C}"/>
+                <a16:creationId xmlns:a16="http://schemas.microsoft.com/office/drawing/2014/main" id="{6F168ABA-E5E9-463A-9EAC-B680596B8F61}"/>
               </a:ext>
             </a:extLst>
           </p:cNvPr>
@@ -5783,10 +5783,10 @@
       </p:sp>
       <p:sp>
         <p:nvSpPr>
-          <p:cNvPr id="11" name="Review the service, price and&#10;availabili">
+          <p:cNvPr id="11" name="Review the service, pricing status&#10;and l">
             <a:extLst xmlns:a="http://schemas.openxmlformats.org/drawingml/2006/main">
               <a:ext uri="{FF2B5EF4-FFF2-40B4-BE49-F238E27FC236}">
-                <a16:creationId xmlns:a16="http://schemas.microsoft.com/office/drawing/2014/main" id="{6A60B86C-4CB4-4841-90CD-58722546215F}"/>
+                <a16:creationId xmlns:a16="http://schemas.microsoft.com/office/drawing/2014/main" id="{D28F80C3-B53B-4EC4-993A-D821DBE26C56}"/>
               </a:ext>
             </a:extLst>
           </p:cNvPr>
@@ -5844,7 +5844,7 @@
                 <a:ea typeface="Manrope"/>
                 <a:cs typeface="Manrope"/>
               </a:rPr>
-              <a:t>Review the service, price and</a:t>
+              <a:t>Review the service, pricing status</a:t>
             </a:r>
           </a:p>
           <a:p xmlns:a="http://schemas.openxmlformats.org/drawingml/2006/main">
@@ -5867,7 +5867,7 @@
                 <a:ea typeface="Manrope"/>
                 <a:cs typeface="Manrope"/>
               </a:rPr>
-              <a:t>availability for your property.</a:t>
+              <a:t>and local availability.</a:t>
             </a:r>
           </a:p>
         </p:txBody>
@@ -5877,7 +5877,7 @@
           <p:cNvPr id="12" name="LakeLife.ai">
             <a:extLst xmlns:a="http://schemas.openxmlformats.org/drawingml/2006/main">
               <a:ext uri="{FF2B5EF4-FFF2-40B4-BE49-F238E27FC236}">
-                <a16:creationId xmlns:a16="http://schemas.microsoft.com/office/drawing/2014/main" id="{301FF1F7-E6FA-4399-8191-C91DFCB0C8EB}"/>
+                <a16:creationId xmlns:a16="http://schemas.microsoft.com/office/drawing/2014/main" id="{5B76078A-7A51-4BE6-B69B-036E2372DFAC}"/>
               </a:ext>
             </a:extLst>
           </p:cNvPr>
@@ -5928,7 +5928,7 @@
             </a:pPr>
             <a:r>
               <a:rPr>
-                <a:hlinkClick xmlns:r="http://schemas.openxmlformats.org/officeDocument/2006/relationships" r:id="R8671b7b877e64c04"/>
+                <a:hlinkClick xmlns:r="http://schemas.openxmlformats.org/officeDocument/2006/relationships" r:id="R563eee669ae94721"/>
               </a:rPr>
               <a:t>LakeLife.ai</a:t>
             </a:r>
@@ -5940,7 +5940,7 @@
           <p:cNvPr id="13" name="Park setup is guided. Local service avai">
             <a:extLst xmlns:a="http://schemas.openxmlformats.org/drawingml/2006/main">
               <a:ext uri="{FF2B5EF4-FFF2-40B4-BE49-F238E27FC236}">
-                <a16:creationId xmlns:a16="http://schemas.microsoft.com/office/drawing/2014/main" id="{A16AD697-2B62-42AB-B785-692CD66C77E1}"/>
+                <a16:creationId xmlns:a16="http://schemas.microsoft.com/office/drawing/2014/main" id="{F93BF2F1-5481-46B8-B565-C080810BE797}"/>
               </a:ext>
             </a:extLst>
           </p:cNvPr>
@@ -6008,7 +6008,7 @@
           <p:cNvPr id="14" name="">
             <a:extLst xmlns:a="http://schemas.openxmlformats.org/drawingml/2006/main">
               <a:ext uri="{FF2B5EF4-FFF2-40B4-BE49-F238E27FC236}">
-                <a16:creationId xmlns:a16="http://schemas.microsoft.com/office/drawing/2014/main" id="{9C0D1AF3-8FD1-408D-8F40-B7809F7D055A}"/>
+                <a16:creationId xmlns:a16="http://schemas.microsoft.com/office/drawing/2014/main" id="{0DD1B73A-08DF-4891-9D66-C17F3EB50AA1}"/>
               </a:ext>
             </a:extLst>
           </p:cNvPr>
@@ -6018,7 +6018,7 @@
           <p:nvPr/>
         </p:nvPicPr>
         <p:blipFill>
-          <a:blip xmlns:r="http://schemas.openxmlformats.org/officeDocument/2006/relationships" xmlns:a="http://schemas.openxmlformats.org/drawingml/2006/main" r:embed="R30651b431b6b4e3d"/>
+          <a:blip xmlns:r="http://schemas.openxmlformats.org/officeDocument/2006/relationships" xmlns:a="http://schemas.openxmlformats.org/drawingml/2006/main" r:embed="Re7621e3cd4324bf5"/>
           <a:stretch xmlns:a="http://schemas.openxmlformats.org/drawingml/2006/main"/>
         </p:blipFill>
         <p:spPr>
@@ -6034,7 +6034,7 @@
     </p:spTree>
     <p:extLst>
       <p:ext uri="{BB962C8B-B14F-4D97-AF65-F5344CB8AC3E}">
-        <p14:creationId xmlns:p14="http://schemas.microsoft.com/office/powerpoint/2010/main" val="1412679329"/>
+        <p14:creationId xmlns:p14="http://schemas.microsoft.com/office/powerpoint/2010/main" val="858541286"/>
       </p:ext>
     </p:extLst>
   </p:cSld>

</xml_diff>